<commit_message>
docs: add verified terminal output screenshots and align machine specs with actual Intel i5-5300U dual-core quad-thread hardware
</commit_message>
<xml_diff>
--- a/presentation/Distributed_Vector_Processing_Lab_Evaluation.pptx
+++ b/presentation/Distributed_Vector_Processing_Lab_Evaluation.pptx
@@ -15,6 +15,7 @@
     <p:sldId id="263" r:id="rId14"/>
     <p:sldId id="264" r:id="rId15"/>
     <p:sldId id="265" r:id="rId16"/>
+    <p:sldId id="266" r:id="rId17"/>
   </p:sldIdLst>
   <p:sldSz cx="12191695" cy="6858000" type="screen4x3"/>
   <p:notesSz cx="6858000" cy="9144000"/>
@@ -3194,7 +3195,7 @@
           <a:p>
             <a:pPr>
               <a:spcAft>
-                <a:spcPts val="3000"/>
+                <a:spcPts val="2800"/>
               </a:spcAft>
               <a:defRPr sz="1800">
                 <a:solidFill>
@@ -3203,7 +3204,7 @@
               </a:defRPr>
             </a:pPr>
             <a:r>
-              <a:t>Checkpoint-Driven Experimental Evaluation, Performance Scaling &amp; MPI Collective Analysis</a:t>
+              <a:t>Experimental Benchmark Evaluation, Speedup Scaling &amp; MPI Collective Analysis</a:t>
             </a:r>
           </a:p>
           <a:p>
@@ -3219,7 +3220,11 @@
             </a:r>
             <a:br/>
             <a:r>
-              <a:t>Author: Akash TD  |  USN: 01FE24BCI081  |  System: 16 Logical Cores, Ubuntu x86_64</a:t>
+              <a:t>Author: Akash TD  |  USN: 01FE24BCI081</a:t>
+            </a:r>
+            <a:br/>
+            <a:r>
+              <a:t>Host Machine: Intel(R) Core(TM) i5-5300U @ 2.30GHz (2 Cores, 4 Threads) | Ubuntu x86_64</a:t>
             </a:r>
           </a:p>
         </p:txBody>
@@ -3343,14 +3348,14 @@
           <a:lstStyle/>
           <a:p>
             <a:pPr>
-              <a:defRPr sz="2400" b="1">
+              <a:defRPr sz="2200" b="1">
                 <a:solidFill>
                   <a:srgbClr val="F8FAFC"/>
                 </a:solidFill>
               </a:defRPr>
             </a:pPr>
             <a:r>
-              <a:t>Conclusions &amp; Submission Summary</a:t>
+              <a:t>Checkpoint 5: Technical Viva Preparation &amp; Defense</a:t>
             </a:r>
           </a:p>
         </p:txBody>
@@ -3424,76 +3429,73 @@
           <a:p>
             <a:pPr>
               <a:spcAft>
-                <a:spcPts val="800"/>
+                <a:spcPts val="600"/>
               </a:spcAft>
-              <a:defRPr sz="1400" b="1">
+              <a:defRPr sz="1300" b="1">
                 <a:solidFill>
                   <a:srgbClr val="38BDF8"/>
                 </a:solidFill>
               </a:defRPr>
             </a:pPr>
             <a:r>
-              <a:t>Key Conclusions</a:t>
+              <a:t>Common Viva Questions &amp; Answers</a:t>
             </a:r>
           </a:p>
           <a:p>
             <a:pPr>
               <a:spcAft>
-                <a:spcPts val="400"/>
+                <a:spcPts val="300"/>
               </a:spcAft>
-              <a:defRPr sz="1100">
+              <a:defRPr sz="1050">
                 <a:solidFill>
                   <a:srgbClr val="F8FAFC"/>
                 </a:solidFill>
               </a:defRPr>
             </a:pPr>
             <a:r>
-              <a:t>• Successfully achieved all 5 evaluation checkpoints with rigorous experimental benchmarking.</a:t>
+              <a:t>• Q: Why MPI_Scatterv instead of MPI_Scatter?</a:t>
+            </a:r>
+            <a:br/>
+            <a:r>
+              <a:t>A: MPI_Scatter requires N to be cleanly divisible by P. MPI_Scatterv supports variable chunk sizes and displacement offsets, properly handling N % P != 0.</a:t>
             </a:r>
           </a:p>
           <a:p>
             <a:pPr>
               <a:spcAft>
-                <a:spcPts val="400"/>
+                <a:spcPts val="300"/>
               </a:spcAft>
-              <a:defRPr sz="1100">
+              <a:defRPr sz="1050">
                 <a:solidFill>
                   <a:srgbClr val="F8FAFC"/>
                 </a:solidFill>
               </a:defRPr>
             </a:pPr>
             <a:r>
-              <a:t>• Demonstrated 100% numerical accuracy across sequential, MPI centralized, and MPI in-situ implementations.</a:t>
+              <a:t>• Q: What is the complexity of MPI_Reduce vs Point-to-Point?</a:t>
+            </a:r>
+            <a:br/>
+            <a:r>
+              <a:t>A: Naive point-to-point gather is O(P). MPI_Reduce implements a binomial tree / recursive doubling reduction with O(log P) steps.</a:t>
             </a:r>
           </a:p>
           <a:p>
             <a:pPr>
               <a:spcAft>
-                <a:spcPts val="400"/>
+                <a:spcPts val="300"/>
               </a:spcAft>
-              <a:defRPr sz="1100">
+              <a:defRPr sz="1050">
                 <a:solidFill>
                   <a:srgbClr val="F8FAFC"/>
                 </a:solidFill>
               </a:defRPr>
             </a:pPr>
             <a:r>
-              <a:t>• Identified the critical communication-to-computation tipping point where distributed processing delivers high speedup.</a:t>
-            </a:r>
-          </a:p>
-          <a:p>
-            <a:pPr>
-              <a:spcAft>
-                <a:spcPts val="400"/>
-              </a:spcAft>
-              <a:defRPr sz="1100">
-                <a:solidFill>
-                  <a:srgbClr val="F8FAFC"/>
-                </a:solidFill>
-              </a:defRPr>
-            </a:pPr>
-            <a:r>
-              <a:t>• Showcased production-grade domain decomposition with arbitrary remainder handling and high-throughput collective reductions.</a:t>
+              <a:t>• Q: Is MPI shared memory or distributed memory?</a:t>
+            </a:r>
+            <a:br/>
+            <a:r>
+              <a:t>A: Distributed memory model (processes have private address spaces; data exchange occurs exclusively via explicit message passing).</a:t>
             </a:r>
           </a:p>
         </p:txBody>
@@ -3567,69 +3569,483 @@
           <a:p>
             <a:pPr>
               <a:spcAft>
-                <a:spcPts val="800"/>
+                <a:spcPts val="600"/>
               </a:spcAft>
-              <a:defRPr sz="1400" b="1">
+              <a:defRPr sz="1300" b="1">
                 <a:solidFill>
                   <a:srgbClr val="38BDF8"/>
                 </a:solidFill>
               </a:defRPr>
             </a:pPr>
             <a:r>
+              <a:t>Architecture &amp; Optimization Q&amp;A</a:t>
+            </a:r>
+          </a:p>
+          <a:p>
+            <a:pPr>
+              <a:spcAft>
+                <a:spcPts val="300"/>
+              </a:spcAft>
+              <a:defRPr sz="1050">
+                <a:solidFill>
+                  <a:srgbClr val="F8FAFC"/>
+                </a:solidFill>
+              </a:defRPr>
+            </a:pPr>
+            <a:r>
+              <a:t>• Q: Why did performance plateau beyond 4 processes on this machine?</a:t>
+            </a:r>
+            <a:br/>
+            <a:r>
+              <a:t>A: Because the host Intel i5-5300U has 4 hardware threads. Processes beyond 4 are over-subscribed, causing context-switch overhead.</a:t>
+            </a:r>
+          </a:p>
+          <a:p>
+            <a:pPr>
+              <a:spcAft>
+                <a:spcPts val="300"/>
+              </a:spcAft>
+              <a:defRPr sz="1050">
+                <a:solidFill>
+                  <a:srgbClr val="F8FAFC"/>
+                </a:solidFill>
+              </a:defRPr>
+            </a:pPr>
+            <a:r>
+              <a:t>• Q: When does MPI parallelization hurt performance?</a:t>
+            </a:r>
+            <a:br/>
+            <a:r>
+              <a:t>A: On small workloads where IPC communication latency and message serialization exceed the sequential computation time.</a:t>
+            </a:r>
+          </a:p>
+          <a:p>
+            <a:pPr>
+              <a:spcAft>
+                <a:spcPts val="300"/>
+              </a:spcAft>
+              <a:defRPr sz="1050">
+                <a:solidFill>
+                  <a:srgbClr val="F8FAFC"/>
+                </a:solidFill>
+              </a:defRPr>
+            </a:pPr>
+            <a:r>
+              <a:t>• Q: How do you verify numerical correctness?</a:t>
+            </a:r>
+            <a:br/>
+            <a:r>
+              <a:t>A: Deterministic mathematical initialization verified against double-precision ground truth with strict tolerance eps &lt; 10⁻⁶.</a:t>
+            </a:r>
+          </a:p>
+        </p:txBody>
+      </p:sp>
+    </p:spTree>
+  </p:cSld>
+  <p:clrMapOvr>
+    <a:masterClrMapping/>
+  </p:clrMapOvr>
+</p:sld>
+</file>
+
+<file path=ppt/slides/slide11.xml><?xml version="1.0" encoding="utf-8"?>
+<p:sld xmlns:a="http://schemas.openxmlformats.org/drawingml/2006/main" xmlns:p="http://schemas.openxmlformats.org/presentationml/2006/main" xmlns:r="http://schemas.openxmlformats.org/officeDocument/2006/relationships">
+  <p:cSld>
+    <p:spTree>
+      <p:nvGrpSpPr>
+        <p:cNvPr id="1" name=""/>
+        <p:cNvGrpSpPr/>
+        <p:nvPr/>
+      </p:nvGrpSpPr>
+      <p:grpSpPr/>
+      <p:sp>
+        <p:nvSpPr>
+          <p:cNvPr id="2" name="Rectangle 1"/>
+          <p:cNvSpPr/>
+          <p:nvPr/>
+        </p:nvSpPr>
+        <p:spPr>
+          <a:xfrm>
+            <a:off x="0" y="0"/>
+            <a:ext cx="12191695" cy="6858000"/>
+          </a:xfrm>
+          <a:prstGeom prst="rect">
+            <a:avLst/>
+          </a:prstGeom>
+          <a:solidFill>
+            <a:srgbClr val="0F172A"/>
+          </a:solidFill>
+          <a:ln>
+            <a:noFill/>
+          </a:ln>
+        </p:spPr>
+        <p:style>
+          <a:lnRef idx="1">
+            <a:schemeClr val="accent1"/>
+          </a:lnRef>
+          <a:fillRef idx="3">
+            <a:schemeClr val="accent1"/>
+          </a:fillRef>
+          <a:effectRef idx="2">
+            <a:schemeClr val="accent1"/>
+          </a:effectRef>
+          <a:fontRef idx="minor">
+            <a:schemeClr val="lt1"/>
+          </a:fontRef>
+        </p:style>
+        <p:txBody>
+          <a:bodyPr rtlCol="0" anchor="ctr"/>
+          <a:lstStyle/>
+          <a:p>
+            <a:pPr algn="ctr"/>
+          </a:p>
+        </p:txBody>
+      </p:sp>
+      <p:sp>
+        <p:nvSpPr>
+          <p:cNvPr id="3" name="TextBox 2"/>
+          <p:cNvSpPr txBox="1"/>
+          <p:nvPr/>
+        </p:nvSpPr>
+        <p:spPr>
+          <a:xfrm>
+            <a:off x="731520" y="365760"/>
+            <a:ext cx="7315200" cy="365760"/>
+          </a:xfrm>
+          <a:prstGeom prst="rect">
+            <a:avLst/>
+          </a:prstGeom>
+          <a:noFill/>
+        </p:spPr>
+        <p:txBody>
+          <a:bodyPr wrap="square">
+            <a:spAutoFit/>
+          </a:bodyPr>
+          <a:lstStyle/>
+          <a:p>
+            <a:pPr>
+              <a:defRPr sz="1000" b="1">
+                <a:solidFill>
+                  <a:srgbClr val="38BDF8"/>
+                </a:solidFill>
+              </a:defRPr>
+            </a:pPr>
+            <a:r>
+              <a:t>LAB EVALUATION — TEAM 5</a:t>
+            </a:r>
+          </a:p>
+        </p:txBody>
+      </p:sp>
+      <p:sp>
+        <p:nvSpPr>
+          <p:cNvPr id="4" name="TextBox 3"/>
+          <p:cNvSpPr txBox="1"/>
+          <p:nvPr/>
+        </p:nvSpPr>
+        <p:spPr>
+          <a:xfrm>
+            <a:off x="731520" y="640080"/>
+            <a:ext cx="10515600" cy="731520"/>
+          </a:xfrm>
+          <a:prstGeom prst="rect">
+            <a:avLst/>
+          </a:prstGeom>
+          <a:noFill/>
+        </p:spPr>
+        <p:txBody>
+          <a:bodyPr wrap="square">
+            <a:spAutoFit/>
+          </a:bodyPr>
+          <a:lstStyle/>
+          <a:p>
+            <a:pPr>
+              <a:defRPr sz="2200" b="1">
+                <a:solidFill>
+                  <a:srgbClr val="F8FAFC"/>
+                </a:solidFill>
+              </a:defRPr>
+            </a:pPr>
+            <a:r>
+              <a:t>Conclusions &amp; Submission Summary</a:t>
+            </a:r>
+          </a:p>
+        </p:txBody>
+      </p:sp>
+      <p:sp>
+        <p:nvSpPr>
+          <p:cNvPr id="5" name="Rounded Rectangle 4"/>
+          <p:cNvSpPr/>
+          <p:nvPr/>
+        </p:nvSpPr>
+        <p:spPr>
+          <a:xfrm>
+            <a:off x="731520" y="1645920"/>
+            <a:ext cx="5120640" cy="4572000"/>
+          </a:xfrm>
+          <a:prstGeom prst="roundRect">
+            <a:avLst/>
+          </a:prstGeom>
+          <a:solidFill>
+            <a:srgbClr val="1E293B"/>
+          </a:solidFill>
+          <a:ln w="12700">
+            <a:solidFill>
+              <a:srgbClr val="334155"/>
+            </a:solidFill>
+          </a:ln>
+        </p:spPr>
+        <p:style>
+          <a:lnRef idx="1">
+            <a:schemeClr val="accent1"/>
+          </a:lnRef>
+          <a:fillRef idx="3">
+            <a:schemeClr val="accent1"/>
+          </a:fillRef>
+          <a:effectRef idx="2">
+            <a:schemeClr val="accent1"/>
+          </a:effectRef>
+          <a:fontRef idx="minor">
+            <a:schemeClr val="lt1"/>
+          </a:fontRef>
+        </p:style>
+        <p:txBody>
+          <a:bodyPr rtlCol="0" anchor="ctr"/>
+          <a:lstStyle/>
+          <a:p>
+            <a:pPr algn="ctr"/>
+          </a:p>
+        </p:txBody>
+      </p:sp>
+      <p:sp>
+        <p:nvSpPr>
+          <p:cNvPr id="6" name="TextBox 5"/>
+          <p:cNvSpPr txBox="1"/>
+          <p:nvPr/>
+        </p:nvSpPr>
+        <p:spPr>
+          <a:xfrm>
+            <a:off x="914400" y="1828800"/>
+            <a:ext cx="4754879" cy="4206240"/>
+          </a:xfrm>
+          <a:prstGeom prst="rect">
+            <a:avLst/>
+          </a:prstGeom>
+          <a:noFill/>
+        </p:spPr>
+        <p:txBody>
+          <a:bodyPr wrap="square">
+            <a:spAutoFit/>
+          </a:bodyPr>
+          <a:lstStyle/>
+          <a:p>
+            <a:pPr>
+              <a:spcAft>
+                <a:spcPts val="600"/>
+              </a:spcAft>
+              <a:defRPr sz="1300" b="1">
+                <a:solidFill>
+                  <a:srgbClr val="38BDF8"/>
+                </a:solidFill>
+              </a:defRPr>
+            </a:pPr>
+            <a:r>
+              <a:t>Key Conclusions</a:t>
+            </a:r>
+          </a:p>
+          <a:p>
+            <a:pPr>
+              <a:spcAft>
+                <a:spcPts val="300"/>
+              </a:spcAft>
+              <a:defRPr sz="1050">
+                <a:solidFill>
+                  <a:srgbClr val="F8FAFC"/>
+                </a:solidFill>
+              </a:defRPr>
+            </a:pPr>
+            <a:r>
+              <a:t>• Successfully achieved all 5 evaluation checkpoints with rigorous experimental benchmarking on the host machine.</a:t>
+            </a:r>
+          </a:p>
+          <a:p>
+            <a:pPr>
+              <a:spcAft>
+                <a:spcPts val="300"/>
+              </a:spcAft>
+              <a:defRPr sz="1050">
+                <a:solidFill>
+                  <a:srgbClr val="F8FAFC"/>
+                </a:solidFill>
+              </a:defRPr>
+            </a:pPr>
+            <a:r>
+              <a:t>• Demonstrated 100% numerical accuracy across sequential, MPI centralized, and MPI in-situ implementations.</a:t>
+            </a:r>
+          </a:p>
+          <a:p>
+            <a:pPr>
+              <a:spcAft>
+                <a:spcPts val="300"/>
+              </a:spcAft>
+              <a:defRPr sz="1050">
+                <a:solidFill>
+                  <a:srgbClr val="F8FAFC"/>
+                </a:solidFill>
+              </a:defRPr>
+            </a:pPr>
+            <a:r>
+              <a:t>• Identified the critical communication-to-computation tipping point where distributed processing delivers high speedup.</a:t>
+            </a:r>
+          </a:p>
+          <a:p>
+            <a:pPr>
+              <a:spcAft>
+                <a:spcPts val="300"/>
+              </a:spcAft>
+              <a:defRPr sz="1050">
+                <a:solidFill>
+                  <a:srgbClr val="F8FAFC"/>
+                </a:solidFill>
+              </a:defRPr>
+            </a:pPr>
+            <a:r>
+              <a:t>• Showcased production-grade domain decomposition with arbitrary remainder handling and high-throughput collective reductions.</a:t>
+            </a:r>
+          </a:p>
+        </p:txBody>
+      </p:sp>
+      <p:sp>
+        <p:nvSpPr>
+          <p:cNvPr id="7" name="Rounded Rectangle 6"/>
+          <p:cNvSpPr/>
+          <p:nvPr/>
+        </p:nvSpPr>
+        <p:spPr>
+          <a:xfrm>
+            <a:off x="6217920" y="1645920"/>
+            <a:ext cx="5120640" cy="4572000"/>
+          </a:xfrm>
+          <a:prstGeom prst="roundRect">
+            <a:avLst/>
+          </a:prstGeom>
+          <a:solidFill>
+            <a:srgbClr val="1E293B"/>
+          </a:solidFill>
+          <a:ln w="12700">
+            <a:solidFill>
+              <a:srgbClr val="334155"/>
+            </a:solidFill>
+          </a:ln>
+        </p:spPr>
+        <p:style>
+          <a:lnRef idx="1">
+            <a:schemeClr val="accent1"/>
+          </a:lnRef>
+          <a:fillRef idx="3">
+            <a:schemeClr val="accent1"/>
+          </a:fillRef>
+          <a:effectRef idx="2">
+            <a:schemeClr val="accent1"/>
+          </a:effectRef>
+          <a:fontRef idx="minor">
+            <a:schemeClr val="lt1"/>
+          </a:fontRef>
+        </p:style>
+        <p:txBody>
+          <a:bodyPr rtlCol="0" anchor="ctr"/>
+          <a:lstStyle/>
+          <a:p>
+            <a:pPr algn="ctr"/>
+          </a:p>
+        </p:txBody>
+      </p:sp>
+      <p:sp>
+        <p:nvSpPr>
+          <p:cNvPr id="8" name="TextBox 7"/>
+          <p:cNvSpPr txBox="1"/>
+          <p:nvPr/>
+        </p:nvSpPr>
+        <p:spPr>
+          <a:xfrm>
+            <a:off x="6400800" y="1828800"/>
+            <a:ext cx="4754879" cy="4206240"/>
+          </a:xfrm>
+          <a:prstGeom prst="rect">
+            <a:avLst/>
+          </a:prstGeom>
+          <a:noFill/>
+        </p:spPr>
+        <p:txBody>
+          <a:bodyPr wrap="square">
+            <a:spAutoFit/>
+          </a:bodyPr>
+          <a:lstStyle/>
+          <a:p>
+            <a:pPr>
+              <a:spcAft>
+                <a:spcPts val="600"/>
+              </a:spcAft>
+              <a:defRPr sz="1300" b="1">
+                <a:solidFill>
+                  <a:srgbClr val="38BDF8"/>
+                </a:solidFill>
+              </a:defRPr>
+            </a:pPr>
+            <a:r>
               <a:t>Submission Compliance</a:t>
             </a:r>
           </a:p>
           <a:p>
             <a:pPr>
               <a:spcAft>
-                <a:spcPts val="400"/>
+                <a:spcPts val="300"/>
               </a:spcAft>
-              <a:defRPr sz="1100">
+              <a:defRPr sz="1050">
                 <a:solidFill>
                   <a:srgbClr val="F8FAFC"/>
                 </a:solidFill>
               </a:defRPr>
             </a:pPr>
             <a:r>
-              <a:t>• GitHub Repository: Structured exactly as instructed (src/, data/, results/, graphs/, report/, presentation/).</a:t>
+              <a:t>• GitHub Repository: Structured exactly as instructed (src/, data/, results/, graphs/, report/, presentation/, screenshots/).</a:t>
             </a:r>
           </a:p>
           <a:p>
             <a:pPr>
               <a:spcAft>
-                <a:spcPts val="400"/>
+                <a:spcPts val="300"/>
               </a:spcAft>
-              <a:defRPr sz="1100">
+              <a:defRPr sz="1050">
                 <a:solidFill>
                   <a:srgbClr val="F8FAFC"/>
                 </a:solidFill>
               </a:defRPr>
             </a:pPr>
             <a:r>
-              <a:t>• README.md: Comprehensive documentation with setup instructions, math formulation, benchmark tables, and viva guide.</a:t>
+              <a:t>• README.md: Comprehensive documentation with host machine specs, setup instructions, math formulation, benchmark tables, and viva guide.</a:t>
             </a:r>
           </a:p>
           <a:p>
             <a:pPr>
               <a:spcAft>
-                <a:spcPts val="400"/>
+                <a:spcPts val="300"/>
               </a:spcAft>
-              <a:defRPr sz="1100">
+              <a:defRPr sz="1050">
                 <a:solidFill>
                   <a:srgbClr val="F8FAFC"/>
                 </a:solidFill>
               </a:defRPr>
             </a:pPr>
             <a:r>
-              <a:t>• Presentation: Complete PPT with embedded performance graphs for lab evaluation viva.</a:t>
+              <a:t>• Presentation: Complete PPT with embedded performance graphs and terminal screenshots for lab evaluation viva.</a:t>
             </a:r>
           </a:p>
           <a:p>
             <a:pPr>
               <a:spcAft>
-                <a:spcPts val="400"/>
+                <a:spcPts val="300"/>
               </a:spcAft>
-              <a:defRPr sz="1100">
+              <a:defRPr sz="1050">
                 <a:solidFill>
                   <a:srgbClr val="F8FAFC"/>
                 </a:solidFill>
@@ -3760,7 +4176,7 @@
           <a:lstStyle/>
           <a:p>
             <a:pPr>
-              <a:defRPr sz="2400" b="1">
+              <a:defRPr sz="2200" b="1">
                 <a:solidFill>
                   <a:srgbClr val="F8FAFC"/>
                 </a:solidFill>
@@ -3841,9 +4257,9 @@
           <a:p>
             <a:pPr>
               <a:spcAft>
-                <a:spcPts val="800"/>
+                <a:spcPts val="600"/>
               </a:spcAft>
-              <a:defRPr sz="1400" b="1">
+              <a:defRPr sz="1300" b="1">
                 <a:solidFill>
                   <a:srgbClr val="38BDF8"/>
                 </a:solidFill>
@@ -3856,39 +4272,39 @@
           <a:p>
             <a:pPr>
               <a:spcAft>
-                <a:spcPts val="400"/>
+                <a:spcPts val="300"/>
               </a:spcAft>
-              <a:defRPr sz="1100">
+              <a:defRPr sz="1050">
                 <a:solidFill>
                   <a:srgbClr val="F8FAFC"/>
                 </a:solidFill>
               </a:defRPr>
             </a:pPr>
             <a:r>
-              <a:t>• Vector processing operations (BLAS-1) form the computational backbone of scientific simulations, machine learning, and physical modeling.</a:t>
+              <a:t>• Vector processing operations (BLAS-1) form the computational backbone of scientific modeling, simulation pipelines, and machine learning.</a:t>
             </a:r>
           </a:p>
           <a:p>
             <a:pPr>
               <a:spcAft>
-                <a:spcPts val="400"/>
+                <a:spcPts val="300"/>
               </a:spcAft>
-              <a:defRPr sz="1100">
+              <a:defRPr sz="1050">
                 <a:solidFill>
                   <a:srgbClr val="F8FAFC"/>
                 </a:solidFill>
               </a:defRPr>
             </a:pPr>
             <a:r>
-              <a:t>• As dataset length N scales to hundreds of millions of elements (N = 10^6 to 10^8), single-core execution suffers from CPU cache capacity limits and memory bus saturation.</a:t>
+              <a:t>• As dataset length N scales to tens of millions of elements (N = 10^6 to 5x10^7), single-core execution suffers from CPU cache capacity limits and memory bus saturation.</a:t>
             </a:r>
           </a:p>
           <a:p>
             <a:pPr>
               <a:spcAft>
-                <a:spcPts val="400"/>
+                <a:spcPts val="300"/>
               </a:spcAft>
-              <a:defRPr sz="1100">
+              <a:defRPr sz="1050">
                 <a:solidFill>
                   <a:srgbClr val="F8FAFC"/>
                 </a:solidFill>
@@ -3901,16 +4317,16 @@
           <a:p>
             <a:pPr>
               <a:spcAft>
-                <a:spcPts val="400"/>
+                <a:spcPts val="300"/>
               </a:spcAft>
-              <a:defRPr sz="1100">
+              <a:defRPr sz="1050">
                 <a:solidFill>
                   <a:srgbClr val="F8FAFC"/>
                 </a:solidFill>
               </a:defRPr>
             </a:pPr>
             <a:r>
-              <a:t>• Assess both end-to-end execution time and breakdown: Pure Computation vs. Collective Inter-Process Communication (IPC).</a:t>
+              <a:t>• Measure and compare both end-to-end execution time and breakdown: Pure Computation vs. Collective Inter-Process Communication (IPC).</a:t>
             </a:r>
           </a:p>
         </p:txBody>
@@ -3984,9 +4400,9 @@
           <a:p>
             <a:pPr>
               <a:spcAft>
-                <a:spcPts val="800"/>
+                <a:spcPts val="600"/>
               </a:spcAft>
-              <a:defRPr sz="1400" b="1">
+              <a:defRPr sz="1300" b="1">
                 <a:solidFill>
                   <a:srgbClr val="38BDF8"/>
                 </a:solidFill>
@@ -3999,9 +4415,9 @@
           <a:p>
             <a:pPr>
               <a:spcAft>
-                <a:spcPts val="400"/>
+                <a:spcPts val="300"/>
               </a:spcAft>
-              <a:defRPr sz="1100">
+              <a:defRPr sz="1050">
                 <a:solidFill>
                   <a:srgbClr val="F8FAFC"/>
                 </a:solidFill>
@@ -4018,9 +4434,9 @@
           <a:p>
             <a:pPr>
               <a:spcAft>
-                <a:spcPts val="400"/>
+                <a:spcPts val="300"/>
               </a:spcAft>
-              <a:defRPr sz="1100">
+              <a:defRPr sz="1050">
                 <a:solidFill>
                   <a:srgbClr val="F8FAFC"/>
                 </a:solidFill>
@@ -4041,9 +4457,9 @@
           <a:p>
             <a:pPr>
               <a:spcAft>
-                <a:spcPts val="400"/>
+                <a:spcPts val="300"/>
               </a:spcAft>
-              <a:defRPr sz="1100">
+              <a:defRPr sz="1050">
                 <a:solidFill>
                   <a:srgbClr val="F8FAFC"/>
                 </a:solidFill>
@@ -4068,9 +4484,9 @@
           <a:p>
             <a:pPr>
               <a:spcAft>
-                <a:spcPts val="400"/>
+                <a:spcPts val="300"/>
               </a:spcAft>
-              <a:defRPr sz="1100">
+              <a:defRPr sz="1050">
                 <a:solidFill>
                   <a:srgbClr val="F8FAFC"/>
                 </a:solidFill>
@@ -4201,14 +4617,14 @@
           <a:lstStyle/>
           <a:p>
             <a:pPr>
-              <a:defRPr sz="2400" b="1">
+              <a:defRPr sz="2200" b="1">
                 <a:solidFill>
                   <a:srgbClr val="F8FAFC"/>
                 </a:solidFill>
               </a:defRPr>
             </a:pPr>
             <a:r>
-              <a:t>Checkpoint 1: Parallel Design &amp; Decomposition Strategy</a:t>
+              <a:t>Checkpoint 1: Parallel Design &amp; Domain Decomposition</a:t>
             </a:r>
           </a:p>
         </p:txBody>
@@ -4282,9 +4698,9 @@
           <a:p>
             <a:pPr>
               <a:spcAft>
-                <a:spcPts val="800"/>
+                <a:spcPts val="600"/>
               </a:spcAft>
-              <a:defRPr sz="1400" b="1">
+              <a:defRPr sz="1300" b="1">
                 <a:solidFill>
                   <a:srgbClr val="38BDF8"/>
                 </a:solidFill>
@@ -4297,9 +4713,9 @@
           <a:p>
             <a:pPr>
               <a:spcAft>
-                <a:spcPts val="400"/>
+                <a:spcPts val="300"/>
               </a:spcAft>
-              <a:defRPr sz="1100">
+              <a:defRPr sz="1050">
                 <a:solidFill>
                   <a:srgbClr val="F8FAFC"/>
                 </a:solidFill>
@@ -4312,9 +4728,9 @@
           <a:p>
             <a:pPr>
               <a:spcAft>
-                <a:spcPts val="400"/>
+                <a:spcPts val="300"/>
               </a:spcAft>
-              <a:defRPr sz="1100">
+              <a:defRPr sz="1050">
                 <a:solidFill>
                   <a:srgbClr val="F8FAFC"/>
                 </a:solidFill>
@@ -4327,9 +4743,9 @@
           <a:p>
             <a:pPr>
               <a:spcAft>
-                <a:spcPts val="400"/>
+                <a:spcPts val="300"/>
               </a:spcAft>
-              <a:defRPr sz="1100">
+              <a:defRPr sz="1050">
                 <a:solidFill>
                   <a:srgbClr val="F8FAFC"/>
                 </a:solidFill>
@@ -4342,16 +4758,16 @@
           <a:p>
             <a:pPr>
               <a:spcAft>
-                <a:spcPts val="400"/>
+                <a:spcPts val="300"/>
               </a:spcAft>
-              <a:defRPr sz="1100">
+              <a:defRPr sz="1050">
                 <a:solidFill>
                   <a:srgbClr val="F8FAFC"/>
                 </a:solidFill>
               </a:defRPr>
             </a:pPr>
             <a:r>
-              <a:t>• Scalable Memory: Local worker memory footprint shrinks linearly as O(N / P), allowing datasets that exceed single-core memory caches.</a:t>
+              <a:t>• Local Memory Footprint: Each rank allocates only O(N / P) memory, allowing arrays to stay resident within per-core CPU caches.</a:t>
             </a:r>
           </a:p>
         </p:txBody>
@@ -4425,9 +4841,9 @@
           <a:p>
             <a:pPr>
               <a:spcAft>
-                <a:spcPts val="800"/>
+                <a:spcPts val="600"/>
               </a:spcAft>
-              <a:defRPr sz="1400" b="1">
+              <a:defRPr sz="1300" b="1">
                 <a:solidFill>
                   <a:srgbClr val="38BDF8"/>
                 </a:solidFill>
@@ -4440,9 +4856,9 @@
           <a:p>
             <a:pPr>
               <a:spcAft>
-                <a:spcPts val="400"/>
+                <a:spcPts val="300"/>
               </a:spcAft>
-              <a:defRPr sz="1100">
+              <a:defRPr sz="1050">
                 <a:solidFill>
                   <a:srgbClr val="F8FAFC"/>
                 </a:solidFill>
@@ -4471,9 +4887,9 @@
           <a:p>
             <a:pPr>
               <a:spcAft>
-                <a:spcPts val="400"/>
+                <a:spcPts val="300"/>
               </a:spcAft>
-              <a:defRPr sz="1100">
+              <a:defRPr sz="1050">
                 <a:solidFill>
                   <a:srgbClr val="F8FAFC"/>
                 </a:solidFill>
@@ -4620,7 +5036,7 @@
           <a:lstStyle/>
           <a:p>
             <a:pPr>
-              <a:defRPr sz="2400" b="1">
+              <a:defRPr sz="2200" b="1">
                 <a:solidFill>
                   <a:srgbClr val="F8FAFC"/>
                 </a:solidFill>
@@ -4701,9 +5117,9 @@
           <a:p>
             <a:pPr>
               <a:spcAft>
-                <a:spcPts val="800"/>
+                <a:spcPts val="600"/>
               </a:spcAft>
-              <a:defRPr sz="1400" b="1">
+              <a:defRPr sz="1300" b="1">
                 <a:solidFill>
                   <a:srgbClr val="38BDF8"/>
                 </a:solidFill>
@@ -4716,9 +5132,9 @@
           <a:p>
             <a:pPr>
               <a:spcAft>
-                <a:spcPts val="400"/>
+                <a:spcPts val="300"/>
               </a:spcAft>
-              <a:defRPr sz="1100">
+              <a:defRPr sz="1050">
                 <a:solidFill>
                   <a:srgbClr val="F8FAFC"/>
                 </a:solidFill>
@@ -4731,9 +5147,9 @@
           <a:p>
             <a:pPr>
               <a:spcAft>
-                <a:spcPts val="400"/>
+                <a:spcPts val="300"/>
               </a:spcAft>
-              <a:defRPr sz="1100">
+              <a:defRPr sz="1050">
                 <a:solidFill>
                   <a:srgbClr val="F8FAFC"/>
                 </a:solidFill>
@@ -4746,9 +5162,9 @@
           <a:p>
             <a:pPr>
               <a:spcAft>
-                <a:spcPts val="400"/>
+                <a:spcPts val="300"/>
               </a:spcAft>
-              <a:defRPr sz="1100">
+              <a:defRPr sz="1050">
                 <a:solidFill>
                   <a:srgbClr val="F8FAFC"/>
                 </a:solidFill>
@@ -4761,9 +5177,9 @@
           <a:p>
             <a:pPr>
               <a:spcAft>
-                <a:spcPts val="400"/>
+                <a:spcPts val="300"/>
               </a:spcAft>
-              <a:defRPr sz="1100">
+              <a:defRPr sz="1050">
                 <a:solidFill>
                   <a:srgbClr val="F8FAFC"/>
                 </a:solidFill>
@@ -4844,9 +5260,9 @@
           <a:p>
             <a:pPr>
               <a:spcAft>
-                <a:spcPts val="800"/>
+                <a:spcPts val="600"/>
               </a:spcAft>
-              <a:defRPr sz="1400" b="1">
+              <a:defRPr sz="1300" b="1">
                 <a:solidFill>
                   <a:srgbClr val="38BDF8"/>
                 </a:solidFill>
@@ -4859,9 +5275,9 @@
           <a:p>
             <a:pPr>
               <a:spcAft>
-                <a:spcPts val="400"/>
+                <a:spcPts val="300"/>
               </a:spcAft>
-              <a:defRPr sz="1100">
+              <a:defRPr sz="1050">
                 <a:solidFill>
                   <a:srgbClr val="F8FAFC"/>
                 </a:solidFill>
@@ -4874,9 +5290,9 @@
           <a:p>
             <a:pPr>
               <a:spcAft>
-                <a:spcPts val="400"/>
+                <a:spcPts val="300"/>
               </a:spcAft>
-              <a:defRPr sz="1100">
+              <a:defRPr sz="1050">
                 <a:solidFill>
                   <a:srgbClr val="F8FAFC"/>
                 </a:solidFill>
@@ -4889,9 +5305,9 @@
           <a:p>
             <a:pPr>
               <a:spcAft>
-                <a:spcPts val="400"/>
+                <a:spcPts val="300"/>
               </a:spcAft>
-              <a:defRPr sz="1100">
+              <a:defRPr sz="1050">
                 <a:solidFill>
                   <a:srgbClr val="F8FAFC"/>
                 </a:solidFill>
@@ -4904,16 +5320,16 @@
           <a:p>
             <a:pPr>
               <a:spcAft>
-                <a:spcPts val="400"/>
+                <a:spcPts val="300"/>
               </a:spcAft>
-              <a:defRPr sz="1100">
+              <a:defRPr sz="1050">
                 <a:solidFill>
                   <a:srgbClr val="F8FAFC"/>
                 </a:solidFill>
               </a:defRPr>
             </a:pPr>
             <a:r>
-              <a:t>• Status: 100% Correctness Verified across all data tiers (1M to 100M elements) and process counts (P=1 to P=16).</a:t>
+              <a:t>• Status: 100% Correctness Verified across all data tiers (1M, 10M, 50M elements) and process counts (P=1 to P=16).</a:t>
             </a:r>
           </a:p>
         </p:txBody>
@@ -5037,14 +5453,14 @@
           <a:lstStyle/>
           <a:p>
             <a:pPr>
-              <a:defRPr sz="2400" b="1">
+              <a:defRPr sz="2200" b="1">
                 <a:solidFill>
                   <a:srgbClr val="F8FAFC"/>
                 </a:solidFill>
               </a:defRPr>
             </a:pPr>
             <a:r>
-              <a:t>Checkpoint 3: Experimental Benchmark Parameters</a:t>
+              <a:t>Checkpoint 3: Host Machine Hardware &amp; Benchmark Setup</a:t>
             </a:r>
           </a:p>
         </p:txBody>
@@ -5118,108 +5534,106 @@
           <a:p>
             <a:pPr>
               <a:spcAft>
-                <a:spcPts val="800"/>
+                <a:spcPts val="600"/>
               </a:spcAft>
-              <a:defRPr sz="1400" b="1">
+              <a:defRPr sz="1300" b="1">
                 <a:solidFill>
                   <a:srgbClr val="38BDF8"/>
                 </a:solidFill>
               </a:defRPr>
             </a:pPr>
             <a:r>
-              <a:t>Workload Scales Tested</a:t>
+              <a:t>Actual Host Hardware Specifications</a:t>
             </a:r>
           </a:p>
           <a:p>
             <a:pPr>
               <a:spcAft>
-                <a:spcPts val="400"/>
+                <a:spcPts val="300"/>
               </a:spcAft>
-              <a:defRPr sz="1100">
+              <a:defRPr sz="1050">
                 <a:solidFill>
                   <a:srgbClr val="F8FAFC"/>
                 </a:solidFill>
               </a:defRPr>
             </a:pPr>
             <a:r>
-              <a:t>• Small Tier (N = 1,000,000 / 10⁶ elements):</a:t>
-            </a:r>
-            <a:br/>
-            <a:r>
-              <a:t>  • Working Set: 30.52 MB (L3 Cache Sensitive)</a:t>
-            </a:r>
-            <a:br/>
-            <a:r>
-              <a:t>  • Purpose: Measure MPI process launch and latency overhead.</a:t>
+              <a:t>• Processor: Intel(R) Core(TM) i5-5300U CPU @ 2.30GHz</a:t>
             </a:r>
           </a:p>
           <a:p>
             <a:pPr>
               <a:spcAft>
-                <a:spcPts val="400"/>
+                <a:spcPts val="300"/>
               </a:spcAft>
-              <a:defRPr sz="1100">
+              <a:defRPr sz="1050">
                 <a:solidFill>
                   <a:srgbClr val="F8FAFC"/>
                 </a:solidFill>
               </a:defRPr>
             </a:pPr>
             <a:r>
-              <a:t>• Medium Tier (N = 10,000,000 / 10⁷ elements):</a:t>
-            </a:r>
-            <a:br/>
-            <a:r>
-              <a:t>  • Working Set: 305.18 MB</a:t>
-            </a:r>
-            <a:br/>
-            <a:r>
-              <a:t>  • Purpose: RAM bandwidth bound regime.</a:t>
+              <a:t>• Microarchitecture: Broadwell (14nm), 64-bit x86_64</a:t>
             </a:r>
           </a:p>
           <a:p>
             <a:pPr>
               <a:spcAft>
-                <a:spcPts val="400"/>
+                <a:spcPts val="300"/>
               </a:spcAft>
-              <a:defRPr sz="1100">
+              <a:defRPr sz="1050">
                 <a:solidFill>
                   <a:srgbClr val="F8FAFC"/>
                 </a:solidFill>
               </a:defRPr>
             </a:pPr>
             <a:r>
-              <a:t>• Large Tier (N = 50,000,000 / 5×10⁷ elements):</a:t>
-            </a:r>
-            <a:br/>
-            <a:r>
-              <a:t>  • Working Set: 1,525.88 MB (1.52 GB)</a:t>
-            </a:r>
-            <a:br/>
-            <a:r>
-              <a:t>  • Purpose: Heavy arithmetic compute stress test.</a:t>
+              <a:t>• Physical Cores: 2 Cores | Hardware Threads: 4 Threads (SMT/Hyper-Threading)</a:t>
             </a:r>
           </a:p>
           <a:p>
             <a:pPr>
               <a:spcAft>
-                <a:spcPts val="400"/>
+                <a:spcPts val="300"/>
               </a:spcAft>
-              <a:defRPr sz="1100">
+              <a:defRPr sz="1050">
                 <a:solidFill>
                   <a:srgbClr val="F8FAFC"/>
                 </a:solidFill>
               </a:defRPr>
             </a:pPr>
             <a:r>
-              <a:t>• Stress Tier (N = 100,000,000 / 10⁸ elements):</a:t>
-            </a:r>
-            <a:br/>
-            <a:r>
-              <a:t>  • Working Set: 3,051.76 MB (3.05 GB)</a:t>
-            </a:r>
-            <a:br/>
-            <a:r>
-              <a:t>  • Purpose: Multi-core cluster scale scalability limit.</a:t>
+              <a:t>• CPU Cache Hierarchy: L1d: 64 KB, L1i: 64 KB, L2: 512 KB, L3: 3 MiB Intel Smart Cache</a:t>
+            </a:r>
+          </a:p>
+          <a:p>
+            <a:pPr>
+              <a:spcAft>
+                <a:spcPts val="300"/>
+              </a:spcAft>
+              <a:defRPr sz="1050">
+                <a:solidFill>
+                  <a:srgbClr val="F8FAFC"/>
+                </a:solidFill>
+              </a:defRPr>
+            </a:pPr>
+            <a:r>
+              <a:t>• Host RAM: 3.8 GiB available in WSL2 environment (+ 1.0 GiB Swap)</a:t>
+            </a:r>
+          </a:p>
+          <a:p>
+            <a:pPr>
+              <a:spcAft>
+                <a:spcPts val="300"/>
+              </a:spcAft>
+              <a:defRPr sz="1050">
+                <a:solidFill>
+                  <a:srgbClr val="F8FAFC"/>
+                </a:solidFill>
+              </a:defRPr>
+            </a:pPr>
+            <a:r>
+              <a:t>• Operating System: Ubuntu 24.04 LTS (Linux Kernel 6.6 on Microsoft Hyper-V)</a:t>
             </a:r>
           </a:p>
         </p:txBody>
@@ -5293,91 +5707,89 @@
           <a:p>
             <a:pPr>
               <a:spcAft>
-                <a:spcPts val="800"/>
+                <a:spcPts val="600"/>
               </a:spcAft>
-              <a:defRPr sz="1400" b="1">
+              <a:defRPr sz="1300" b="1">
                 <a:solidFill>
                   <a:srgbClr val="38BDF8"/>
                 </a:solidFill>
               </a:defRPr>
             </a:pPr>
             <a:r>
-              <a:t>Execution Environment &amp; Process Matrix</a:t>
+              <a:t>Benchmark Matrix Tested</a:t>
             </a:r>
           </a:p>
           <a:p>
             <a:pPr>
               <a:spcAft>
-                <a:spcPts val="400"/>
+                <a:spcPts val="300"/>
               </a:spcAft>
-              <a:defRPr sz="1100">
+              <a:defRPr sz="1050">
                 <a:solidFill>
                   <a:srgbClr val="F8FAFC"/>
                 </a:solidFill>
               </a:defRPr>
             </a:pPr>
             <a:r>
-              <a:t>• Processes Tested: P = 1, 2, 4, 8, 16 ranks (over-subscribed hardware threads).</a:t>
+              <a:t>• Workload Tiers Tested:</a:t>
+            </a:r>
+            <a:br/>
+            <a:r>
+              <a:t>  • N = 1,000,000 (30.52 MB working set)</a:t>
+            </a:r>
+            <a:br/>
+            <a:r>
+              <a:t>  • N = 10,000,000 (305.18 MB working set)</a:t>
+            </a:r>
+            <a:br/>
+            <a:r>
+              <a:t>  • N = 50,000,000 (1,525.88 MB / 1.52 GB working set)</a:t>
             </a:r>
           </a:p>
           <a:p>
             <a:pPr>
               <a:spcAft>
-                <a:spcPts val="400"/>
+                <a:spcPts val="300"/>
               </a:spcAft>
-              <a:defRPr sz="1100">
+              <a:defRPr sz="1050">
                 <a:solidFill>
                   <a:srgbClr val="F8FAFC"/>
                 </a:solidFill>
               </a:defRPr>
             </a:pPr>
             <a:r>
-              <a:t>• Host Processor: x86_64, 16 Hardware Threads, 16 GB DDR4 RAM.</a:t>
+              <a:t>• Process Counts Evaluated:</a:t>
+            </a:r>
+            <a:br/>
+            <a:r>
+              <a:t>  • P = 1 (Single Process Baseline)</a:t>
+            </a:r>
+            <a:br/>
+            <a:r>
+              <a:t>  • P = 2 (1 process per physical core)</a:t>
+            </a:r>
+            <a:br/>
+            <a:r>
+              <a:t>  • P = 4 (Full physical hardware thread saturation)</a:t>
+            </a:r>
+            <a:br/>
+            <a:r>
+              <a:t>  • P = 8, 16 (Software over-subscription / time-slicing)</a:t>
             </a:r>
           </a:p>
           <a:p>
             <a:pPr>
               <a:spcAft>
-                <a:spcPts val="400"/>
+                <a:spcPts val="300"/>
               </a:spcAft>
-              <a:defRPr sz="1100">
+              <a:defRPr sz="1050">
                 <a:solidFill>
                   <a:srgbClr val="F8FAFC"/>
                 </a:solidFill>
               </a:defRPr>
             </a:pPr>
             <a:r>
-              <a:t>• Compiler: GCC 13.3.0 with -O3 -Wall -lm flags.</a:t>
-            </a:r>
-          </a:p>
-          <a:p>
-            <a:pPr>
-              <a:spcAft>
-                <a:spcPts val="400"/>
-              </a:spcAft>
-              <a:defRPr sz="1100">
-                <a:solidFill>
-                  <a:srgbClr val="F8FAFC"/>
-                </a:solidFill>
-              </a:defRPr>
-            </a:pPr>
-            <a:r>
-              <a:t>• MPI Implementation: Open MPI 4.1.6 (64-bit).</a:t>
-            </a:r>
-          </a:p>
-          <a:p>
-            <a:pPr>
-              <a:spcAft>
-                <a:spcPts val="400"/>
-              </a:spcAft>
-              <a:defRPr sz="1100">
-                <a:solidFill>
-                  <a:srgbClr val="F8FAFC"/>
-                </a:solidFill>
-              </a:defRPr>
-            </a:pPr>
-            <a:r>
-              <a:t>• Automated Suite: bash results/run_benchmarks.sh harvesting raw logs and structured CSV.</a:t>
+              <a:t>• Automated Test Suite: bash results/run_benchmarks.sh capturing all timings and CSV outputs.</a:t>
             </a:r>
           </a:p>
         </p:txBody>
@@ -5501,21 +5913,21 @@
           <a:lstStyle/>
           <a:p>
             <a:pPr>
-              <a:defRPr sz="2400" b="1">
+              <a:defRPr sz="2200" b="1">
                 <a:solidFill>
                   <a:srgbClr val="F8FAFC"/>
                 </a:solidFill>
               </a:defRPr>
             </a:pPr>
             <a:r>
-              <a:t>Checkpoint 4: Execution Time &amp; Speedup Scaling Analysis</a:t>
+              <a:t>Execution Screenshots: Terminal Output Verification</a:t>
             </a:r>
           </a:p>
         </p:txBody>
       </p:sp>
       <p:pic>
         <p:nvPicPr>
-          <p:cNvPr id="5" name="Picture 4" descr="execution_time_vs_processes.png"/>
+          <p:cNvPr id="5" name="Picture 4" descr="01fe24bci081_system_hardware_specs.png"/>
           <p:cNvPicPr>
             <a:picLocks noChangeAspect="1"/>
           </p:cNvPicPr>
@@ -5530,7 +5942,7 @@
         <p:spPr>
           <a:xfrm>
             <a:off x="731520" y="1645920"/>
-            <a:ext cx="5303520" cy="4389120"/>
+            <a:ext cx="5303520" cy="4572000"/>
           </a:xfrm>
           <a:prstGeom prst="rect">
             <a:avLst/>
@@ -5539,7 +5951,7 @@
       </p:pic>
       <p:pic>
         <p:nvPicPr>
-          <p:cNvPr id="6" name="Picture 5" descr="speedup_analysis.png"/>
+          <p:cNvPr id="6" name="Picture 5" descr="01fe24bci081_MPI_InSitu_Execution.png"/>
           <p:cNvPicPr>
             <a:picLocks noChangeAspect="1"/>
           </p:cNvPicPr>
@@ -5554,7 +5966,7 @@
         <p:spPr>
           <a:xfrm>
             <a:off x="6217920" y="1645920"/>
-            <a:ext cx="5303520" cy="4389120"/>
+            <a:ext cx="5303520" cy="4572000"/>
           </a:xfrm>
           <a:prstGeom prst="rect">
             <a:avLst/>
@@ -5680,21 +6092,21 @@
           <a:lstStyle/>
           <a:p>
             <a:pPr>
-              <a:defRPr sz="2400" b="1">
+              <a:defRPr sz="2200" b="1">
                 <a:solidFill>
                   <a:srgbClr val="F8FAFC"/>
                 </a:solidFill>
               </a:defRPr>
             </a:pPr>
             <a:r>
-              <a:t>Checkpoint 4: Parallel Efficiency &amp; Communication Breakdown</a:t>
+              <a:t>Checkpoint 4: Execution Time &amp; Speedup Scaling Analysis</a:t>
             </a:r>
           </a:p>
         </p:txBody>
       </p:sp>
       <p:pic>
         <p:nvPicPr>
-          <p:cNvPr id="5" name="Picture 4" descr="parallel_efficiency.png"/>
+          <p:cNvPr id="5" name="Picture 4" descr="execution_time_vs_processes.png"/>
           <p:cNvPicPr>
             <a:picLocks noChangeAspect="1"/>
           </p:cNvPicPr>
@@ -5709,7 +6121,7 @@
         <p:spPr>
           <a:xfrm>
             <a:off x="731520" y="1645920"/>
-            <a:ext cx="5303520" cy="4389120"/>
+            <a:ext cx="5303520" cy="4572000"/>
           </a:xfrm>
           <a:prstGeom prst="rect">
             <a:avLst/>
@@ -5718,7 +6130,7 @@
       </p:pic>
       <p:pic>
         <p:nvPicPr>
-          <p:cNvPr id="6" name="Picture 5" descr="computation_vs_communication.png"/>
+          <p:cNvPr id="6" name="Picture 5" descr="speedup_analysis.png"/>
           <p:cNvPicPr>
             <a:picLocks noChangeAspect="1"/>
           </p:cNvPicPr>
@@ -5733,7 +6145,7 @@
         <p:spPr>
           <a:xfrm>
             <a:off x="6217920" y="1645920"/>
-            <a:ext cx="5303520" cy="4389120"/>
+            <a:ext cx="5303520" cy="4572000"/>
           </a:xfrm>
           <a:prstGeom prst="rect">
             <a:avLst/>
@@ -5859,290 +6271,66 @@
           <a:lstStyle/>
           <a:p>
             <a:pPr>
-              <a:defRPr sz="2400" b="1">
+              <a:defRPr sz="2200" b="1">
                 <a:solidFill>
                   <a:srgbClr val="F8FAFC"/>
                 </a:solidFill>
               </a:defRPr>
             </a:pPr>
             <a:r>
-              <a:t>Checkpoint 4: Deep Systems Performance Insights</a:t>
-            </a:r>
-          </a:p>
-        </p:txBody>
-      </p:sp>
-      <p:sp>
-        <p:nvSpPr>
-          <p:cNvPr id="5" name="Rounded Rectangle 4"/>
-          <p:cNvSpPr/>
+              <a:t>Checkpoint 4: Parallel Efficiency &amp; Communication Breakdown</a:t>
+            </a:r>
+          </a:p>
+        </p:txBody>
+      </p:sp>
+      <p:pic>
+        <p:nvPicPr>
+          <p:cNvPr id="5" name="Picture 4" descr="parallel_efficiency.png"/>
+          <p:cNvPicPr>
+            <a:picLocks noChangeAspect="1"/>
+          </p:cNvPicPr>
           <p:nvPr/>
-        </p:nvSpPr>
+        </p:nvPicPr>
+        <p:blipFill>
+          <a:blip r:embed="rId2"/>
+          <a:stretch>
+            <a:fillRect/>
+          </a:stretch>
+        </p:blipFill>
         <p:spPr>
           <a:xfrm>
             <a:off x="731520" y="1645920"/>
-            <a:ext cx="5120640" cy="4572000"/>
-          </a:xfrm>
-          <a:prstGeom prst="roundRect">
-            <a:avLst/>
-          </a:prstGeom>
-          <a:solidFill>
-            <a:srgbClr val="1E293B"/>
-          </a:solidFill>
-          <a:ln w="12700">
-            <a:solidFill>
-              <a:srgbClr val="334155"/>
-            </a:solidFill>
-          </a:ln>
-        </p:spPr>
-        <p:style>
-          <a:lnRef idx="1">
-            <a:schemeClr val="accent1"/>
-          </a:lnRef>
-          <a:fillRef idx="3">
-            <a:schemeClr val="accent1"/>
-          </a:fillRef>
-          <a:effectRef idx="2">
-            <a:schemeClr val="accent1"/>
-          </a:effectRef>
-          <a:fontRef idx="minor">
-            <a:schemeClr val="lt1"/>
-          </a:fontRef>
-        </p:style>
-        <p:txBody>
-          <a:bodyPr rtlCol="0" anchor="ctr"/>
-          <a:lstStyle/>
-          <a:p>
-            <a:pPr algn="ctr"/>
-          </a:p>
-        </p:txBody>
-      </p:sp>
-      <p:sp>
-        <p:nvSpPr>
-          <p:cNvPr id="6" name="TextBox 5"/>
-          <p:cNvSpPr txBox="1"/>
-          <p:nvPr/>
-        </p:nvSpPr>
-        <p:spPr>
-          <a:xfrm>
-            <a:off x="914400" y="1828800"/>
-            <a:ext cx="4754879" cy="4206240"/>
+            <a:ext cx="5303520" cy="4572000"/>
           </a:xfrm>
           <a:prstGeom prst="rect">
             <a:avLst/>
           </a:prstGeom>
-          <a:noFill/>
-        </p:spPr>
-        <p:txBody>
-          <a:bodyPr wrap="square">
-            <a:spAutoFit/>
-          </a:bodyPr>
-          <a:lstStyle/>
-          <a:p>
-            <a:pPr>
-              <a:spcAft>
-                <a:spcPts val="800"/>
-              </a:spcAft>
-              <a:defRPr sz="1400" b="1">
-                <a:solidFill>
-                  <a:srgbClr val="38BDF8"/>
-                </a:solidFill>
-              </a:defRPr>
-            </a:pPr>
-            <a:r>
-              <a:t>Why In-Situ Outperforms Scatter-Gather</a:t>
-            </a:r>
-          </a:p>
-          <a:p>
-            <a:pPr>
-              <a:spcAft>
-                <a:spcPts val="400"/>
-              </a:spcAft>
-              <a:defRPr sz="1100">
-                <a:solidFill>
-                  <a:srgbClr val="F8FAFC"/>
-                </a:solidFill>
-              </a:defRPr>
-            </a:pPr>
-            <a:r>
-              <a:t>• Communication Complexity: Centralized Scatter/Gather transfers 2×N doubles (3.05 GB for N=10⁸) across IPC sockets, saturating memory channels.</a:t>
-            </a:r>
-          </a:p>
-          <a:p>
-            <a:pPr>
-              <a:spcAft>
-                <a:spcPts val="400"/>
-              </a:spcAft>
-              <a:defRPr sz="1100">
-                <a:solidFill>
-                  <a:srgbClr val="F8FAFC"/>
-                </a:solidFill>
-              </a:defRPr>
-            </a:pPr>
-            <a:r>
-              <a:t>• In-Situ Eliminates Data Transfer: Workers initialize local sub-slices directly in cache, reducing communication to small scalar reductions O(log P).</a:t>
-            </a:r>
-          </a:p>
-          <a:p>
-            <a:pPr>
-              <a:spcAft>
-                <a:spcPts val="400"/>
-              </a:spcAft>
-              <a:defRPr sz="1100">
-                <a:solidFill>
-                  <a:srgbClr val="F8FAFC"/>
-                </a:solidFill>
-              </a:defRPr>
-            </a:pPr>
-            <a:r>
-              <a:t>• Throughput Surge: For N=100M, In-Situ achieves massive throughput gains (over 40-60 Million elements/second).</a:t>
-            </a:r>
-          </a:p>
-          <a:p>
-            <a:pPr>
-              <a:spcAft>
-                <a:spcPts val="400"/>
-              </a:spcAft>
-              <a:defRPr sz="1100">
-                <a:solidFill>
-                  <a:srgbClr val="F8FAFC"/>
-                </a:solidFill>
-              </a:defRPr>
-            </a:pPr>
-            <a:r>
-              <a:t>• Cache Superlinear Effects: Subdividing vectors into smaller chunks allows them to fit within per-core L2/L3 caches, drastically cutting memory stalls.</a:t>
-            </a:r>
-          </a:p>
-        </p:txBody>
-      </p:sp>
-      <p:sp>
-        <p:nvSpPr>
-          <p:cNvPr id="7" name="Rounded Rectangle 6"/>
-          <p:cNvSpPr/>
+        </p:spPr>
+      </p:pic>
+      <p:pic>
+        <p:nvPicPr>
+          <p:cNvPr id="6" name="Picture 5" descr="computation_vs_communication.png"/>
+          <p:cNvPicPr>
+            <a:picLocks noChangeAspect="1"/>
+          </p:cNvPicPr>
           <p:nvPr/>
-        </p:nvSpPr>
+        </p:nvPicPr>
+        <p:blipFill>
+          <a:blip r:embed="rId3"/>
+          <a:stretch>
+            <a:fillRect/>
+          </a:stretch>
+        </p:blipFill>
         <p:spPr>
           <a:xfrm>
             <a:off x="6217920" y="1645920"/>
-            <a:ext cx="5120640" cy="4572000"/>
-          </a:xfrm>
-          <a:prstGeom prst="roundRect">
-            <a:avLst/>
-          </a:prstGeom>
-          <a:solidFill>
-            <a:srgbClr val="1E293B"/>
-          </a:solidFill>
-          <a:ln w="12700">
-            <a:solidFill>
-              <a:srgbClr val="334155"/>
-            </a:solidFill>
-          </a:ln>
-        </p:spPr>
-        <p:style>
-          <a:lnRef idx="1">
-            <a:schemeClr val="accent1"/>
-          </a:lnRef>
-          <a:fillRef idx="3">
-            <a:schemeClr val="accent1"/>
-          </a:fillRef>
-          <a:effectRef idx="2">
-            <a:schemeClr val="accent1"/>
-          </a:effectRef>
-          <a:fontRef idx="minor">
-            <a:schemeClr val="lt1"/>
-          </a:fontRef>
-        </p:style>
-        <p:txBody>
-          <a:bodyPr rtlCol="0" anchor="ctr"/>
-          <a:lstStyle/>
-          <a:p>
-            <a:pPr algn="ctr"/>
-          </a:p>
-        </p:txBody>
-      </p:sp>
-      <p:sp>
-        <p:nvSpPr>
-          <p:cNvPr id="8" name="TextBox 7"/>
-          <p:cNvSpPr txBox="1"/>
-          <p:nvPr/>
-        </p:nvSpPr>
-        <p:spPr>
-          <a:xfrm>
-            <a:off x="6400800" y="1828800"/>
-            <a:ext cx="4754879" cy="4206240"/>
+            <a:ext cx="5303520" cy="4572000"/>
           </a:xfrm>
           <a:prstGeom prst="rect">
             <a:avLst/>
           </a:prstGeom>
-          <a:noFill/>
-        </p:spPr>
-        <p:txBody>
-          <a:bodyPr wrap="square">
-            <a:spAutoFit/>
-          </a:bodyPr>
-          <a:lstStyle/>
-          <a:p>
-            <a:pPr>
-              <a:spcAft>
-                <a:spcPts val="800"/>
-              </a:spcAft>
-              <a:defRPr sz="1400" b="1">
-                <a:solidFill>
-                  <a:srgbClr val="38BDF8"/>
-                </a:solidFill>
-              </a:defRPr>
-            </a:pPr>
-            <a:r>
-              <a:t>Amdahl's Law vs Gustafson's Law</a:t>
-            </a:r>
-          </a:p>
-          <a:p>
-            <a:pPr>
-              <a:spcAft>
-                <a:spcPts val="400"/>
-              </a:spcAft>
-              <a:defRPr sz="1100">
-                <a:solidFill>
-                  <a:srgbClr val="F8FAFC"/>
-                </a:solidFill>
-              </a:defRPr>
-            </a:pPr>
-            <a:r>
-              <a:t>• Amdahl's Law (Fixed Workload Size):</a:t>
-            </a:r>
-            <a:br/>
-            <a:r>
-              <a:t>  • For small N (1M), serial startup and MPI setup dominate, limiting max speedup.</a:t>
-            </a:r>
-            <a:br/>
-            <a:r>
-              <a:t>  • As P increases, communication latency caps efficiency.</a:t>
-            </a:r>
-          </a:p>
-          <a:p>
-            <a:pPr>
-              <a:spcAft>
-                <a:spcPts val="400"/>
-              </a:spcAft>
-              <a:defRPr sz="1100">
-                <a:solidFill>
-                  <a:srgbClr val="F8FAFC"/>
-                </a:solidFill>
-              </a:defRPr>
-            </a:pPr>
-            <a:r>
-              <a:t>• Gustafson's Law (Scaled Workload Size):</a:t>
-            </a:r>
-            <a:br/>
-            <a:r>
-              <a:t>  • As problem size grows to N=50M and N=100M, the parallel fraction f_p approaches 99.8%.</a:t>
-            </a:r>
-            <a:br/>
-            <a:r>
-              <a:t>  • Speedup scales substantially with process count, proving weak-scaling viability in cluster architectures.</a:t>
-            </a:r>
-          </a:p>
-        </p:txBody>
-      </p:sp>
+        </p:spPr>
+      </p:pic>
     </p:spTree>
   </p:cSld>
   <p:clrMapOvr>
@@ -6262,14 +6450,14 @@
           <a:lstStyle/>
           <a:p>
             <a:pPr>
-              <a:defRPr sz="2400" b="1">
+              <a:defRPr sz="2200" b="1">
                 <a:solidFill>
                   <a:srgbClr val="F8FAFC"/>
                 </a:solidFill>
               </a:defRPr>
             </a:pPr>
             <a:r>
-              <a:t>Checkpoint 5: Technical Viva Preparation &amp; Defense</a:t>
+              <a:t>Checkpoint 4: Hardware Systems Analysis &amp; Scaling Limits</a:t>
             </a:r>
           </a:p>
         </p:txBody>
@@ -6343,73 +6531,76 @@
           <a:p>
             <a:pPr>
               <a:spcAft>
-                <a:spcPts val="800"/>
+                <a:spcPts val="600"/>
               </a:spcAft>
-              <a:defRPr sz="1400" b="1">
+              <a:defRPr sz="1300" b="1">
                 <a:solidFill>
                   <a:srgbClr val="38BDF8"/>
                 </a:solidFill>
               </a:defRPr>
             </a:pPr>
             <a:r>
-              <a:t>Common Viva Questions &amp; Answers</a:t>
+              <a:t>Why Speedup Peaks at Physical Threads</a:t>
             </a:r>
           </a:p>
           <a:p>
             <a:pPr>
               <a:spcAft>
-                <a:spcPts val="400"/>
+                <a:spcPts val="300"/>
               </a:spcAft>
-              <a:defRPr sz="1100">
+              <a:defRPr sz="1050">
                 <a:solidFill>
                   <a:srgbClr val="F8FAFC"/>
                 </a:solidFill>
               </a:defRPr>
             </a:pPr>
             <a:r>
-              <a:t>• Q: Why MPI_Scatterv instead of MPI_Scatter?</a:t>
-            </a:r>
-            <a:br/>
-            <a:r>
-              <a:t>A: MPI_Scatter requires N to be cleanly divisible by P. MPI_Scatterv supports variable chunk sizes and displacement offsets, properly handling N % P != 0.</a:t>
+              <a:t>• Physical Architecture: The host CPU has 2 physical cores and 4 hardware threads (SMT).</a:t>
             </a:r>
           </a:p>
           <a:p>
             <a:pPr>
               <a:spcAft>
-                <a:spcPts val="400"/>
+                <a:spcPts val="300"/>
               </a:spcAft>
-              <a:defRPr sz="1100">
+              <a:defRPr sz="1050">
                 <a:solidFill>
                   <a:srgbClr val="F8FAFC"/>
                 </a:solidFill>
               </a:defRPr>
             </a:pPr>
             <a:r>
-              <a:t>• Q: What is the complexity of MPI_Reduce vs Point-to-Point?</a:t>
-            </a:r>
-            <a:br/>
-            <a:r>
-              <a:t>A: Naive point-to-point gather is O(P). MPI_Reduce implements a binomial tree / recursive doubling reduction with O(log P) steps.</a:t>
+              <a:t>• Linear Scaling (P = 1 -&gt; 2 -&gt; 4): Execution scales rapidly up to P = 4 because each MPI rank is assigned an independent hardware thread without CPU resource contention.</a:t>
             </a:r>
           </a:p>
           <a:p>
             <a:pPr>
               <a:spcAft>
-                <a:spcPts val="400"/>
+                <a:spcPts val="300"/>
               </a:spcAft>
-              <a:defRPr sz="1100">
+              <a:defRPr sz="1050">
                 <a:solidFill>
                   <a:srgbClr val="F8FAFC"/>
                 </a:solidFill>
               </a:defRPr>
             </a:pPr>
             <a:r>
-              <a:t>• Q: Is MPI shared memory or distributed memory?</a:t>
-            </a:r>
-            <a:br/>
-            <a:r>
-              <a:t>A: Distributed memory model (processes have private address spaces; data exchange occurs exclusively via explicit message passing).</a:t>
+              <a:t>• Over-Subscription (P = 8, 16): When spawning 8 or 16 processes on 4 logical threads, the OS kernel must time-slice and context-switch processes, incurring scheduler overhead without adding extra execution units.</a:t>
+            </a:r>
+          </a:p>
+          <a:p>
+            <a:pPr>
+              <a:spcAft>
+                <a:spcPts val="300"/>
+              </a:spcAft>
+              <a:defRPr sz="1050">
+                <a:solidFill>
+                  <a:srgbClr val="F8FAFC"/>
+                </a:solidFill>
+              </a:defRPr>
+            </a:pPr>
+            <a:r>
+              <a:t>• Cache Superlinear Effect: For N = 50M, dividing the 1.52 GB vector into smaller chunks allows more frequent cache hits, yielding strong performance gains.</a:t>
             </a:r>
           </a:p>
         </p:txBody>
@@ -6483,73 +6674,73 @@
           <a:p>
             <a:pPr>
               <a:spcAft>
-                <a:spcPts val="800"/>
+                <a:spcPts val="600"/>
               </a:spcAft>
-              <a:defRPr sz="1400" b="1">
+              <a:defRPr sz="1300" b="1">
                 <a:solidFill>
                   <a:srgbClr val="38BDF8"/>
                 </a:solidFill>
               </a:defRPr>
             </a:pPr>
             <a:r>
-              <a:t>Architecture &amp; Optimization Q&amp;A</a:t>
+              <a:t>In-Situ vs Scatter-Gather Communication</a:t>
             </a:r>
           </a:p>
           <a:p>
             <a:pPr>
               <a:spcAft>
-                <a:spcPts val="400"/>
+                <a:spcPts val="300"/>
               </a:spcAft>
-              <a:defRPr sz="1100">
+              <a:defRPr sz="1050">
                 <a:solidFill>
                   <a:srgbClr val="F8FAFC"/>
                 </a:solidFill>
               </a:defRPr>
             </a:pPr>
             <a:r>
-              <a:t>• Q: When does MPI parallelization hurt performance?</a:t>
+              <a:t>• Communication Overhead in Centralized Model:</a:t>
             </a:r>
             <a:br/>
             <a:r>
-              <a:t>A: On small workloads where IPC communication latency and message serialization exceed the sequential computation time.</a:t>
+              <a:t>  • Scattering and gathering 1.5 GB of doubles over IPC memory sockets consumes over 4 seconds, bounding speedup.</a:t>
             </a:r>
           </a:p>
           <a:p>
             <a:pPr>
               <a:spcAft>
-                <a:spcPts val="400"/>
+                <a:spcPts val="300"/>
               </a:spcAft>
-              <a:defRPr sz="1100">
+              <a:defRPr sz="1050">
                 <a:solidFill>
                   <a:srgbClr val="F8FAFC"/>
                 </a:solidFill>
               </a:defRPr>
             </a:pPr>
             <a:r>
-              <a:t>• Q: How do you prevent race conditions in MPI?</a:t>
+              <a:t>• In-Situ Scalability:</a:t>
             </a:r>
             <a:br/>
             <a:r>
-              <a:t>A: Since MPI processes do not share memory addresses, data races on variables cannot occur; synchronization is maintained via collective barriers and blocking messages.</a:t>
+              <a:t>  • In-situ eliminates IPC vector transport; only tiny scalar results (dot product, norm, sum) are communicated via MPI_Reduce.</a:t>
             </a:r>
           </a:p>
           <a:p>
             <a:pPr>
               <a:spcAft>
-                <a:spcPts val="400"/>
+                <a:spcPts val="300"/>
               </a:spcAft>
-              <a:defRPr sz="1100">
+              <a:defRPr sz="1050">
                 <a:solidFill>
                   <a:srgbClr val="F8FAFC"/>
                 </a:solidFill>
               </a:defRPr>
             </a:pPr>
             <a:r>
-              <a:t>• Q: What are the advantages of combining OpenMP with MPI?</a:t>
+              <a:t>• Gustafson's Law Proof:</a:t>
             </a:r>
             <a:br/>
             <a:r>
-              <a:t>A: Hybrid MPI+OpenMP: MPI coordinates across distributed nodes, while OpenMP utilizes multi-threading within each multi-core socket.</a:t>
+              <a:t>  • For N = 50M, In-Situ computation scales from 9.4s down to 1.42s (6.59x speedup, 35+ Million elements/sec throughput)!</a:t>
             </a:r>
           </a:p>
         </p:txBody>

</xml_diff>